<commit_message>
cv2.drawContours(hand, [cnt], -1, 255, -1)
</commit_message>
<xml_diff>
--- a/python/ex12/2412747_kadai12.pptx
+++ b/python/ex12/2412747_kadai12.pptx
@@ -107,6 +107,11 @@
       </a:defRPr>
     </a:lvl9pPr>
   </p:defaultTextStyle>
+  <p:extLst>
+    <p:ext uri="{EFAFB233-063F-42B5-8137-9DF3F51BA10A}">
+      <p15:sldGuideLst xmlns:p15="http://schemas.microsoft.com/office/powerpoint/2012/main"/>
+    </p:ext>
+  </p:extLst>
 </p:presentation>
 </file>
 
@@ -3823,6 +3828,93 @@
               <a:rPr kumimoji="1" lang="ja-JP" altLang="en-US"/>
               <a:t>特徴量の設計</a:t>
             </a:r>
+          </a:p>
+        </p:txBody>
+      </p:sp>
+      <p:sp>
+        <p:nvSpPr>
+          <p:cNvPr id="3" name="テキスト ボックス 2">
+            <a:extLst>
+              <a:ext uri="{FF2B5EF4-FFF2-40B4-BE49-F238E27FC236}">
+                <a16:creationId xmlns:a16="http://schemas.microsoft.com/office/drawing/2014/main" id="{0B4DF2D4-8F37-04AE-692F-216AD171AFEB}"/>
+              </a:ext>
+            </a:extLst>
+          </p:cNvPr>
+          <p:cNvSpPr txBox="1"/>
+          <p:nvPr/>
+        </p:nvSpPr>
+        <p:spPr>
+          <a:xfrm>
+            <a:off x="838200" y="1690688"/>
+            <a:ext cx="8802410" cy="2308324"/>
+          </a:xfrm>
+          <a:prstGeom prst="rect">
+            <a:avLst/>
+          </a:prstGeom>
+          <a:noFill/>
+        </p:spPr>
+        <p:txBody>
+          <a:bodyPr wrap="none" rtlCol="0">
+            <a:spAutoFit/>
+          </a:bodyPr>
+          <a:lstStyle/>
+          <a:p>
+            <a:r>
+              <a:rPr kumimoji="1" lang="en-US" altLang="ja-JP" sz="2400" dirty="0"/>
+              <a:t>HOG</a:t>
+            </a:r>
+            <a:r>
+              <a:rPr kumimoji="1" lang="ja-JP" altLang="en-US" sz="2400"/>
+              <a:t>特徴量とは？</a:t>
+            </a:r>
+            <a:endParaRPr kumimoji="1" lang="en-US" altLang="ja-JP" sz="2400" dirty="0"/>
+          </a:p>
+          <a:p>
+            <a:r>
+              <a:rPr kumimoji="1" lang="ja-JP" altLang="en-US" sz="2400"/>
+              <a:t>画像を局所的な領域に分けて、その中での画素値の勾配方向を</a:t>
+            </a:r>
+            <a:endParaRPr kumimoji="1" lang="en-US" altLang="ja-JP" sz="2400" dirty="0"/>
+          </a:p>
+          <a:p>
+            <a:r>
+              <a:rPr lang="ja-JP" altLang="en-US" sz="2400"/>
+              <a:t>ヒストグラム化</a:t>
+            </a:r>
+            <a:r>
+              <a:rPr lang="en-US" altLang="ja-JP" sz="2400" dirty="0"/>
+              <a:t>(81</a:t>
+            </a:r>
+            <a:r>
+              <a:rPr lang="ja-JP" altLang="en-US" sz="2400"/>
+              <a:t>次元化</a:t>
+            </a:r>
+            <a:r>
+              <a:rPr lang="en-US" altLang="ja-JP" sz="2400" dirty="0"/>
+              <a:t>)</a:t>
+            </a:r>
+            <a:r>
+              <a:rPr lang="ja-JP" altLang="en-US" sz="2400"/>
+              <a:t>したもの</a:t>
+            </a:r>
+            <a:endParaRPr lang="en-US" altLang="ja-JP" sz="2400" dirty="0"/>
+          </a:p>
+          <a:p>
+            <a:r>
+              <a:rPr kumimoji="1" lang="en-US" altLang="ja-JP" sz="2400" dirty="0"/>
+              <a:t>→</a:t>
+            </a:r>
+            <a:r>
+              <a:rPr kumimoji="1" lang="ja-JP" altLang="en-US" sz="2400"/>
+              <a:t>つまり領域内で線がどの方向に引かれているかがわかる！</a:t>
+            </a:r>
+            <a:endParaRPr kumimoji="1" lang="en-US" altLang="ja-JP" sz="2400" dirty="0"/>
+          </a:p>
+          <a:p>
+            <a:endParaRPr lang="en-US" altLang="ja-JP" sz="2400" dirty="0"/>
+          </a:p>
+          <a:p>
+            <a:endParaRPr kumimoji="1" lang="ja-JP" altLang="en-US" sz="2400"/>
           </a:p>
         </p:txBody>
       </p:sp>

</xml_diff>

<commit_message>
fin:ex7, ex8, ex11, ex12
</commit_message>
<xml_diff>
--- a/python/ex12/2412747_kadai12.pptx
+++ b/python/ex12/2412747_kadai12.pptx
@@ -8,7 +8,6 @@
     <p:sldId id="257" r:id="rId2"/>
     <p:sldId id="258" r:id="rId3"/>
     <p:sldId id="260" r:id="rId4"/>
-    <p:sldId id="259" r:id="rId5"/>
   </p:sldIdLst>
   <p:sldSz cx="12192000" cy="6858000"/>
   <p:notesSz cx="6858000" cy="9144000"/>
@@ -3846,7 +3845,7 @@
         <p:spPr>
           <a:xfrm>
             <a:off x="838200" y="1690688"/>
-            <a:ext cx="8802410" cy="2308324"/>
+            <a:ext cx="10341293" cy="3785652"/>
           </a:xfrm>
           <a:prstGeom prst="rect">
             <a:avLst/>
@@ -3914,7 +3913,43 @@
             <a:endParaRPr lang="en-US" altLang="ja-JP" sz="2400" dirty="0"/>
           </a:p>
           <a:p>
-            <a:endParaRPr kumimoji="1" lang="ja-JP" altLang="en-US" sz="2400"/>
+            <a:r>
+              <a:rPr kumimoji="1" lang="en" altLang="ja-JP" sz="2400" dirty="0"/>
+              <a:t>cv2.HOGDescriptor((28, 28), (14, 14), (7, 7), (14, 14), 9)</a:t>
+            </a:r>
+            <a:r>
+              <a:rPr kumimoji="1" lang="ja-JP" altLang="en-US" sz="2400"/>
+              <a:t>で設定</a:t>
+            </a:r>
+            <a:endParaRPr kumimoji="1" lang="en-US" altLang="ja-JP" sz="2400" dirty="0"/>
+          </a:p>
+          <a:p>
+            <a:r>
+              <a:rPr kumimoji="1" lang="ja-JP" altLang="en-US" sz="2400"/>
+              <a:t>引数は、画像領域の大きさ、正規化領域の大きさ、ブロックの移動間隔、</a:t>
+            </a:r>
+            <a:endParaRPr kumimoji="1" lang="en-US" altLang="ja-JP" sz="2400" dirty="0"/>
+          </a:p>
+          <a:p>
+            <a:r>
+              <a:rPr lang="ja-JP" altLang="en-US" sz="2400"/>
+              <a:t>ブロックの大きさ、勾配方向の分割数</a:t>
+            </a:r>
+            <a:endParaRPr lang="en-US" altLang="ja-JP" sz="2400" dirty="0"/>
+          </a:p>
+          <a:p>
+            <a:r>
+              <a:rPr kumimoji="1" lang="ja-JP" altLang="en-US" sz="2400"/>
+              <a:t>となっている</a:t>
+            </a:r>
+            <a:endParaRPr kumimoji="1" lang="en-US" altLang="ja-JP" sz="2400" dirty="0"/>
+          </a:p>
+          <a:p>
+            <a:r>
+              <a:rPr lang="ja-JP" altLang="en-US" sz="2400"/>
+              <a:t>これで、画像の数字の特徴量が効率的に取れる！</a:t>
+            </a:r>
+            <a:endParaRPr kumimoji="1" lang="en-US" altLang="ja-JP" sz="2400" dirty="0"/>
           </a:p>
         </p:txBody>
       </p:sp>
@@ -3980,67 +4015,12 @@
           </a:p>
         </p:txBody>
       </p:sp>
-    </p:spTree>
-    <p:extLst>
-      <p:ext uri="{BB962C8B-B14F-4D97-AF65-F5344CB8AC3E}">
-        <p14:creationId xmlns:p14="http://schemas.microsoft.com/office/powerpoint/2010/main" val="626470220"/>
-      </p:ext>
-    </p:extLst>
-  </p:cSld>
-  <p:clrMapOvr>
-    <a:masterClrMapping/>
-  </p:clrMapOvr>
-</p:sld>
-</file>
-
-<file path=ppt/slides/slide4.xml><?xml version="1.0" encoding="utf-8"?>
-<p:sld xmlns:a="http://schemas.openxmlformats.org/drawingml/2006/main" xmlns:r="http://schemas.openxmlformats.org/officeDocument/2006/relationships" xmlns:p="http://schemas.openxmlformats.org/presentationml/2006/main">
-  <p:cSld>
-    <p:spTree>
-      <p:nvGrpSpPr>
-        <p:cNvPr id="1" name=""/>
-        <p:cNvGrpSpPr/>
-        <p:nvPr/>
-      </p:nvGrpSpPr>
-      <p:grpSpPr>
-        <a:xfrm>
-          <a:off x="0" y="0"/>
-          <a:ext cx="0" cy="0"/>
-          <a:chOff x="0" y="0"/>
-          <a:chExt cx="0" cy="0"/>
-        </a:xfrm>
-      </p:grpSpPr>
-      <p:sp>
-        <p:nvSpPr>
-          <p:cNvPr id="2" name="タイトル 1">
-            <a:extLst>
-              <a:ext uri="{FF2B5EF4-FFF2-40B4-BE49-F238E27FC236}">
-                <a16:creationId xmlns:a16="http://schemas.microsoft.com/office/drawing/2014/main" id="{67197BFC-A177-A9E9-63AD-334D0AF6510D}"/>
-              </a:ext>
-            </a:extLst>
-          </p:cNvPr>
-          <p:cNvSpPr>
-            <a:spLocks noGrp="1"/>
-          </p:cNvSpPr>
-          <p:nvPr>
-            <p:ph type="title"/>
-          </p:nvPr>
-        </p:nvSpPr>
-        <p:spPr/>
-        <p:txBody>
-          <a:bodyPr/>
-          <a:lstStyle/>
-          <a:p>
-            <a:endParaRPr kumimoji="1" lang="ja-JP" altLang="en-US"/>
-          </a:p>
-        </p:txBody>
-      </p:sp>
-      <p:sp>
-        <p:nvSpPr>
-          <p:cNvPr id="4" name="テキスト ボックス 3">
-            <a:extLst>
-              <a:ext uri="{FF2B5EF4-FFF2-40B4-BE49-F238E27FC236}">
-                <a16:creationId xmlns:a16="http://schemas.microsoft.com/office/drawing/2014/main" id="{E02FDF2F-80AB-51E8-22CB-2A1321E25E3A}"/>
+      <p:sp>
+        <p:nvSpPr>
+          <p:cNvPr id="3" name="テキスト ボックス 2">
+            <a:extLst>
+              <a:ext uri="{FF2B5EF4-FFF2-40B4-BE49-F238E27FC236}">
+                <a16:creationId xmlns:a16="http://schemas.microsoft.com/office/drawing/2014/main" id="{1D8AE408-CD38-118A-CE25-FDDCCDF7ABB8}"/>
               </a:ext>
             </a:extLst>
           </p:cNvPr>
@@ -4049,8 +4029,8 @@
         </p:nvSpPr>
         <p:spPr>
           <a:xfrm>
-            <a:off x="347730" y="2274838"/>
-            <a:ext cx="16533693" cy="2308324"/>
+            <a:off x="838200" y="1690688"/>
+            <a:ext cx="9171100" cy="4154984"/>
           </a:xfrm>
           <a:prstGeom prst="rect">
             <a:avLst/>
@@ -4064,119 +4044,131 @@
           <a:lstStyle/>
           <a:p>
             <a:r>
-              <a:rPr lang="ja-JP" altLang="ja-JP" b="1"/>
-              <a:t>HOG特徴 + SVM</a:t>
-            </a:r>
-          </a:p>
-          <a:p>
-            <a:r>
-              <a:rPr lang="ja-JP" altLang="ja-JP" b="1"/>
-              <a:t>考え方</a:t>
-            </a:r>
-            <a:r>
-              <a:rPr lang="ja-JP" altLang="ja-JP"/>
-              <a:t>　画像から</a:t>
-            </a:r>
-            <a:r>
-              <a:rPr lang="ja-JP" altLang="ja-JP" b="1"/>
-              <a:t>形を表す特徴量を設計</a:t>
-            </a:r>
-            <a:r>
-              <a:rPr lang="ja-JP" altLang="ja-JP"/>
-              <a:t>し、その特徴で</a:t>
-            </a:r>
-            <a:r>
-              <a:rPr lang="ja-JP" altLang="ja-JP" b="1"/>
-              <a:t>クラスを分ける境界を学習</a:t>
-            </a:r>
-            <a:r>
-              <a:rPr lang="ja-JP" altLang="ja-JP"/>
-              <a:t>する手法（課題11と対照的）。</a:t>
-            </a:r>
-          </a:p>
-          <a:p>
-            <a:r>
-              <a:rPr lang="ja-JP" altLang="ja-JP" b="1"/>
-              <a:t>前処理の追加</a:t>
-            </a:r>
-            <a:r>
-              <a:rPr lang="ja-JP" altLang="ja-JP"/>
-              <a:t>　**deskew（傾き補正）**で数字の傾きをまっすぐにする。</a:t>
-            </a:r>
-          </a:p>
-          <a:p>
-            <a:r>
-              <a:rPr lang="ja-JP" altLang="ja-JP" b="1"/>
-              <a:t>特徴（HOG）</a:t>
-            </a:r>
-            <a:r>
-              <a:rPr lang="ja-JP" altLang="ja-JP"/>
-              <a:t>　画像を小領域に分け、各領域で</a:t>
-            </a:r>
-            <a:r>
-              <a:rPr lang="ja-JP" altLang="ja-JP" b="1"/>
-              <a:t>線がどの向きに走っているか</a:t>
-            </a:r>
-            <a:r>
-              <a:rPr lang="ja-JP" altLang="ja-JP"/>
-              <a:t>をヒストグラム化（81次元）。生ピクセルより字形の違いに強い。</a:t>
-            </a:r>
-          </a:p>
-          <a:p>
-            <a:r>
-              <a:rPr lang="ja-JP" altLang="ja-JP" b="1"/>
-              <a:t>分類器（SVM）</a:t>
-            </a:r>
-            <a:r>
-              <a:rPr lang="ja-JP" altLang="ja-JP"/>
-              <a:t>　HOG特徴を cv2.ml.SVM（RBFカーネル）で学習。各数字を分ける</a:t>
-            </a:r>
-            <a:r>
-              <a:rPr lang="ja-JP" altLang="ja-JP" b="1"/>
-              <a:t>マージン最大の境界</a:t>
-            </a:r>
-            <a:r>
-              <a:rPr lang="ja-JP" altLang="ja-JP"/>
-              <a:t>を引く。多クラス対応なので0〜9を一度に扱える。</a:t>
-            </a:r>
-          </a:p>
-          <a:p>
-            <a:r>
-              <a:rPr lang="ja-JP" altLang="ja-JP" b="1"/>
-              <a:t>長所</a:t>
-            </a:r>
-            <a:r>
-              <a:rPr lang="ja-JP" altLang="ja-JP"/>
-              <a:t>　形を捉えるため高精度になりやすい。</a:t>
-            </a:r>
-            <a:r>
-              <a:rPr lang="ja-JP" altLang="ja-JP" b="1"/>
-              <a:t>短所</a:t>
-            </a:r>
-            <a:r>
-              <a:rPr lang="ja-JP" altLang="ja-JP"/>
-              <a:t>　特徴設計やパラメータ（C・γ）の調整が必要。</a:t>
-            </a:r>
-          </a:p>
-          <a:p>
-            <a:r>
-              <a:rPr lang="ja-JP" altLang="ja-JP" b="1"/>
-              <a:t>図のアイデア</a:t>
-            </a:r>
-            <a:r>
-              <a:rPr lang="ja-JP" altLang="ja-JP"/>
-              <a:t>　各セルの勾配方向ヒストグラム（HOG）の図と、SVMがマージン最大で境界を引く図。</a:t>
-            </a:r>
-          </a:p>
-          <a:p>
-            <a:endParaRPr kumimoji="1" lang="ja-JP" altLang="en-US"/>
+              <a:rPr kumimoji="1" lang="ja-JP" altLang="en-US" sz="2400"/>
+              <a:t>機械学習の定番の</a:t>
+            </a:r>
+            <a:r>
+              <a:rPr kumimoji="1" lang="en-US" altLang="ja-JP" sz="2400" dirty="0"/>
+              <a:t>SVM</a:t>
+            </a:r>
+            <a:r>
+              <a:rPr kumimoji="1" lang="ja-JP" altLang="en-US" sz="2400"/>
+              <a:t>分類器を使用</a:t>
+            </a:r>
+            <a:endParaRPr kumimoji="1" lang="en-US" altLang="ja-JP" sz="2400" dirty="0"/>
+          </a:p>
+          <a:p>
+            <a:r>
+              <a:rPr lang="en-US" altLang="ja-JP" sz="2400" dirty="0"/>
+              <a:t>SVM</a:t>
+            </a:r>
+            <a:r>
+              <a:rPr lang="ja-JP" altLang="en-US" sz="2400"/>
+              <a:t>とは、特徴量をもとにデータを複数のクラスへ分類するもの</a:t>
+            </a:r>
+            <a:endParaRPr lang="en-US" altLang="ja-JP" sz="2400" dirty="0"/>
+          </a:p>
+          <a:p>
+            <a:r>
+              <a:rPr kumimoji="1" lang="en-US" altLang="ja-JP" sz="2400" dirty="0"/>
+              <a:t>HOG</a:t>
+            </a:r>
+            <a:r>
+              <a:rPr kumimoji="1" lang="ja-JP" altLang="en-US" sz="2400"/>
+              <a:t>特徴量を見て、どのクラスに属するかを判定できる</a:t>
+            </a:r>
+            <a:endParaRPr kumimoji="1" lang="en-US" altLang="ja-JP" sz="2400" dirty="0"/>
+          </a:p>
+          <a:p>
+            <a:endParaRPr lang="en-US" altLang="ja-JP" sz="2400" dirty="0"/>
+          </a:p>
+          <a:p>
+            <a:r>
+              <a:rPr kumimoji="1" lang="ja-JP" altLang="en-US" sz="2400"/>
+              <a:t>今回は</a:t>
+            </a:r>
+            <a:r>
+              <a:rPr kumimoji="1" lang="en-US" altLang="ja-JP" sz="2400" dirty="0"/>
+              <a:t>RBF</a:t>
+            </a:r>
+            <a:r>
+              <a:rPr kumimoji="1" lang="ja-JP" altLang="en-US" sz="2400"/>
+              <a:t>カーネルというものを使用して分類</a:t>
+            </a:r>
+            <a:endParaRPr kumimoji="1" lang="en-US" altLang="ja-JP" sz="2400" dirty="0"/>
+          </a:p>
+          <a:p>
+            <a:r>
+              <a:rPr lang="ja-JP" altLang="en-US" sz="2400"/>
+              <a:t>これは複雑な特徴量を分類するのに非常に向いている</a:t>
+            </a:r>
+            <a:endParaRPr lang="en-US" altLang="ja-JP" sz="2400" dirty="0"/>
+          </a:p>
+          <a:p>
+            <a:r>
+              <a:rPr kumimoji="1" lang="ja-JP" altLang="en-US" sz="2400"/>
+              <a:t>ただし、ガンマ値と</a:t>
+            </a:r>
+            <a:r>
+              <a:rPr kumimoji="1" lang="en-US" altLang="ja-JP" sz="2400" dirty="0"/>
+              <a:t>C</a:t>
+            </a:r>
+            <a:r>
+              <a:rPr kumimoji="1" lang="ja-JP" altLang="en-US" sz="2400"/>
+              <a:t>値を調整してあげる必要がある</a:t>
+            </a:r>
+            <a:endParaRPr kumimoji="1" lang="en-US" altLang="ja-JP" sz="2400" dirty="0"/>
+          </a:p>
+          <a:p>
+            <a:r>
+              <a:rPr lang="en-US" altLang="ja-JP" sz="2400" dirty="0"/>
+              <a:t>←</a:t>
+            </a:r>
+            <a:r>
+              <a:rPr lang="ja-JP" altLang="en-US" sz="2400"/>
+              <a:t>ガンマ値：</a:t>
+            </a:r>
+            <a:r>
+              <a:rPr lang="en-US" altLang="ja-JP" sz="2400" dirty="0"/>
+              <a:t>1</a:t>
+            </a:r>
+            <a:r>
+              <a:rPr lang="ja-JP" altLang="en-US" sz="2400"/>
+              <a:t>つの学習データが周囲にどれほど影響するか</a:t>
+            </a:r>
+            <a:endParaRPr lang="en-US" altLang="ja-JP" sz="2400" dirty="0"/>
+          </a:p>
+          <a:p>
+            <a:r>
+              <a:rPr kumimoji="1" lang="ja-JP" altLang="en-US" sz="2400"/>
+              <a:t>　</a:t>
+            </a:r>
+            <a:r>
+              <a:rPr kumimoji="1" lang="en-US" altLang="ja-JP" sz="2400" dirty="0"/>
+              <a:t>C</a:t>
+            </a:r>
+            <a:r>
+              <a:rPr kumimoji="1" lang="ja-JP" altLang="en-US" sz="2400"/>
+              <a:t>値：学習データの誤分類をどれほど厳しく扱うか</a:t>
+            </a:r>
+            <a:endParaRPr kumimoji="1" lang="en-US" altLang="ja-JP" sz="2400" dirty="0"/>
+          </a:p>
+          <a:p>
+            <a:endParaRPr kumimoji="1" lang="en-US" altLang="ja-JP" sz="2400" dirty="0"/>
+          </a:p>
+          <a:p>
+            <a:r>
+              <a:rPr lang="ja-JP" altLang="en-US" sz="2400"/>
+              <a:t>この方法で数字が簡潔に分類できた！</a:t>
+            </a:r>
+            <a:endParaRPr kumimoji="1" lang="ja-JP" altLang="en-US" sz="2400"/>
           </a:p>
         </p:txBody>
       </p:sp>
     </p:spTree>
     <p:extLst>
       <p:ext uri="{BB962C8B-B14F-4D97-AF65-F5344CB8AC3E}">
-        <p14:creationId xmlns:p14="http://schemas.microsoft.com/office/powerpoint/2010/main" val="1958397075"/>
+        <p14:creationId xmlns:p14="http://schemas.microsoft.com/office/powerpoint/2010/main" val="626470220"/>
       </p:ext>
     </p:extLst>
   </p:cSld>

</xml_diff>